<commit_message>
Keep ASR demo focused on project-trained models
</commit_message>
<xml_diff>
--- a/slides/khmer_asr_presentation.pptx
+++ b/slides/khmer_asr_presentation.pptx
@@ -5711,7 +5711,7 @@
               <a:buNone/>
             </a:pPr>
             <a:r>
-              <a:rPr sz="1500" b="1">
+              <a:rPr sz="1500" b="1" dirty="0">
                 <a:solidFill>
                   <a:srgbClr val="1E2761"/>
                 </a:solidFill>
@@ -5721,7 +5721,7 @@
               </a:rPr>
               <a:t>The linguistic challenge of Khmer</a:t>
             </a:r>
-            <a:endParaRPr sz="1500"/>
+            <a:endParaRPr sz="1500" dirty="0"/>
           </a:p>
         </p:txBody>
       </p:sp>
@@ -5833,7 +5833,7 @@
               <a:buNone/>
             </a:pPr>
             <a:r>
-              <a:rPr sz="1300" b="1">
+              <a:rPr sz="1300" b="1" dirty="0">
                 <a:solidFill>
                   <a:srgbClr val="222633"/>
                 </a:solidFill>
@@ -5845,7 +5845,7 @@
 </a:t>
             </a:r>
             <a:r>
-              <a:rPr sz="1150">
+              <a:rPr sz="1150" dirty="0">
                 <a:solidFill>
                   <a:srgbClr val="5B6472"/>
                 </a:solidFill>
@@ -5855,7 +5855,7 @@
               </a:rPr>
               <a:t>Written without consistent spaces between words; context helps identify word boundaries.</a:t>
             </a:r>
-            <a:endParaRPr sz="1300"/>
+            <a:endParaRPr sz="1300" dirty="0"/>
           </a:p>
         </p:txBody>
       </p:sp>
@@ -5960,14 +5960,13 @@
           <a:bodyPr wrap="square" lIns="0" tIns="0" rIns="0" bIns="0" anchor="t"/>
           <a:lstStyle/>
           <a:p>
-            <a:pPr marL="0" indent="0">
+            <a:pPr>
               <a:lnSpc>
                 <a:spcPct val="110000"/>
               </a:lnSpc>
-              <a:buNone/>
-            </a:pPr>
-            <a:r>
-              <a:rPr sz="1300" b="1">
+            </a:pPr>
+            <a:r>
+              <a:rPr sz="1300" b="1" dirty="0">
                 <a:solidFill>
                   <a:srgbClr val="222633"/>
                 </a:solidFill>
@@ -5975,11 +5974,11 @@
                 <a:ea typeface="Calibri"/>
                 <a:cs typeface="Calibri"/>
               </a:rPr>
-              <a:t>Intricate orthography
+              <a:t>Intricate 
 </a:t>
             </a:r>
             <a:r>
-              <a:rPr sz="1150">
+              <a:rPr sz="1150" dirty="0">
                 <a:solidFill>
                   <a:srgbClr val="5B6472"/>
                 </a:solidFill>
@@ -5987,9 +5986,52 @@
                 <a:ea typeface="Calibri"/>
                 <a:cs typeface="Calibri"/>
               </a:rPr>
-              <a:t>Consonant series, dependent vowels, and stacked subscript consonants (Cheung).</a:t>
-            </a:r>
-            <a:endParaRPr sz="1300"/>
+              <a:t>Consonant series, </a:t>
+            </a:r>
+            <a:r>
+              <a:rPr sz="1150" dirty="0" err="1">
+                <a:solidFill>
+                  <a:srgbClr val="5B6472"/>
+                </a:solidFill>
+                <a:latin typeface="Calibri"/>
+                <a:ea typeface="Calibri"/>
+                <a:cs typeface="Calibri"/>
+              </a:rPr>
+              <a:t>depe</a:t>
+            </a:r>
+            <a:r>
+              <a:rPr lang="en-US" sz="1200" b="1" dirty="0" err="1">
+                <a:solidFill>
+                  <a:srgbClr val="222633"/>
+                </a:solidFill>
+                <a:ea typeface="Calibri"/>
+                <a:cs typeface="Calibri"/>
+              </a:rPr>
+              <a:t>orthography</a:t>
+            </a:r>
+            <a:r>
+              <a:rPr sz="1150" dirty="0" err="1">
+                <a:solidFill>
+                  <a:srgbClr val="5B6472"/>
+                </a:solidFill>
+                <a:latin typeface="Calibri"/>
+                <a:ea typeface="Calibri"/>
+                <a:cs typeface="Calibri"/>
+              </a:rPr>
+              <a:t>ndent</a:t>
+            </a:r>
+            <a:r>
+              <a:rPr sz="1150" dirty="0">
+                <a:solidFill>
+                  <a:srgbClr val="5B6472"/>
+                </a:solidFill>
+                <a:latin typeface="Calibri"/>
+                <a:ea typeface="Calibri"/>
+                <a:cs typeface="Calibri"/>
+              </a:rPr>
+              <a:t> vowels, and stacked subscript consonants (Cheung).</a:t>
+            </a:r>
+            <a:endParaRPr sz="1300" dirty="0"/>
           </a:p>
         </p:txBody>
       </p:sp>

</xml_diff>